<commit_message>
Order the unit's topics the way the Maarif curriculum introduces them
The topics are numbered 01 free fall, 02 two-dimensional constant
acceleration, 03 Newton's laws of motion — the order they were asked for and
the order the Maarif curriculum follows, kinematics before dynamics.

Renumbered and reordered everywhere: the homepage topic grid and deck list,
each page's eyebrow and footer, the previous/next strip that walks the unit,
the three decks (cover eyebrow and footer, all regenerated and revalidated)
and the README tables and sections.

Co-Authored-By: Claude Opus 5 (1M context) <noreply@anthropic.com>
</commit_message>
<xml_diff>
--- a/dist/sunum/iki-boyutta-hareket.pptx
+++ b/dist/sunum/iki-boyutta-hareket.pptx
@@ -7524,7 +7524,7 @@
                 <a:ea typeface="Calibri" pitchFamily="34" charset="-122"/>
                 <a:cs typeface="Calibri" pitchFamily="34" charset="-120"/>
               </a:rPr>
-              <a:t>KUVVET VE HAREKET · KONU 03</a:t>
+              <a:t>KUVVET VE HAREKET · KONU 02</a:t>
             </a:r>
             <a:endParaRPr lang="en-US" sz="1300" dirty="0"/>
           </a:p>
@@ -8733,7 +8733,7 @@
                 <a:ea typeface="Calibri" pitchFamily="34" charset="-122"/>
                 <a:cs typeface="Calibri" pitchFamily="34" charset="-120"/>
               </a:rPr>
-              <a:t>Kuvvet ve Hareket · Konu 03 · İki boyutta sabit ivmeli hareket</a:t>
+              <a:t>Kuvvet ve Hareket · Konu 02 · İki boyutta sabit ivmeli hareket</a:t>
             </a:r>
             <a:endParaRPr lang="en-US" sz="1050" dirty="0"/>
           </a:p>
@@ -9699,7 +9699,7 @@
                 <a:ea typeface="Calibri" pitchFamily="34" charset="-122"/>
                 <a:cs typeface="Calibri" pitchFamily="34" charset="-120"/>
               </a:rPr>
-              <a:t>Kuvvet ve Hareket · Konu 03 · İki boyutta sabit ivmeli hareket</a:t>
+              <a:t>Kuvvet ve Hareket · Konu 02 · İki boyutta sabit ivmeli hareket</a:t>
             </a:r>
             <a:endParaRPr lang="en-US" sz="1050" dirty="0"/>
           </a:p>
@@ -10829,7 +10829,7 @@
                 <a:ea typeface="Calibri" pitchFamily="34" charset="-122"/>
                 <a:cs typeface="Calibri" pitchFamily="34" charset="-120"/>
               </a:rPr>
-              <a:t>Kuvvet ve Hareket · Konu 03 · İki boyutta sabit ivmeli hareket</a:t>
+              <a:t>Kuvvet ve Hareket · Konu 02 · İki boyutta sabit ivmeli hareket</a:t>
             </a:r>
             <a:endParaRPr lang="en-US" sz="1050" dirty="0"/>
           </a:p>
@@ -12221,7 +12221,7 @@
                 <a:ea typeface="Calibri" pitchFamily="34" charset="-122"/>
                 <a:cs typeface="Calibri" pitchFamily="34" charset="-120"/>
               </a:rPr>
-              <a:t>Kuvvet ve Hareket · Konu 03 · İki boyutta sabit ivmeli hareket</a:t>
+              <a:t>Kuvvet ve Hareket · Konu 02 · İki boyutta sabit ivmeli hareket</a:t>
             </a:r>
             <a:endParaRPr lang="en-US" sz="1050" dirty="0"/>
           </a:p>
@@ -14136,7 +14136,7 @@
                 <a:ea typeface="Calibri" pitchFamily="34" charset="-122"/>
                 <a:cs typeface="Calibri" pitchFamily="34" charset="-120"/>
               </a:rPr>
-              <a:t>Kuvvet ve Hareket · Konu 03 · İki boyutta sabit ivmeli hareket</a:t>
+              <a:t>Kuvvet ve Hareket · Konu 02 · İki boyutta sabit ivmeli hareket</a:t>
             </a:r>
             <a:endParaRPr lang="en-US" sz="1050" dirty="0"/>
           </a:p>
@@ -15205,7 +15205,7 @@
                 <a:ea typeface="Calibri" pitchFamily="34" charset="-122"/>
                 <a:cs typeface="Calibri" pitchFamily="34" charset="-120"/>
               </a:rPr>
-              <a:t>Kuvvet ve Hareket · Konu 03 · İki boyutta sabit ivmeli hareket</a:t>
+              <a:t>Kuvvet ve Hareket · Konu 02 · İki boyutta sabit ivmeli hareket</a:t>
             </a:r>
             <a:endParaRPr lang="en-US" sz="1050" dirty="0"/>
           </a:p>
@@ -16194,7 +16194,7 @@
                 <a:ea typeface="Calibri" pitchFamily="34" charset="-122"/>
                 <a:cs typeface="Calibri" pitchFamily="34" charset="-120"/>
               </a:rPr>
-              <a:t>Kuvvet ve Hareket · Konu 03 · İki boyutta sabit ivmeli hareket</a:t>
+              <a:t>Kuvvet ve Hareket · Konu 02 · İki boyutta sabit ivmeli hareket</a:t>
             </a:r>
             <a:endParaRPr lang="en-US" sz="1050" dirty="0"/>
           </a:p>
@@ -17461,7 +17461,7 @@
                 <a:ea typeface="Calibri" pitchFamily="34" charset="-122"/>
                 <a:cs typeface="Calibri" pitchFamily="34" charset="-120"/>
               </a:rPr>
-              <a:t>Kuvvet ve Hareket · Konu 03 · İki boyutta sabit ivmeli hareket</a:t>
+              <a:t>Kuvvet ve Hareket · Konu 02 · İki boyutta sabit ivmeli hareket</a:t>
             </a:r>
             <a:endParaRPr lang="en-US" sz="1050" dirty="0"/>
           </a:p>
@@ -18159,7 +18159,7 @@
                 <a:ea typeface="Calibri" pitchFamily="34" charset="-122"/>
                 <a:cs typeface="Calibri" pitchFamily="34" charset="-120"/>
               </a:rPr>
-              <a:t>Kuvvet ve Hareket · Konu 03 · İki boyutta sabit ivmeli hareket</a:t>
+              <a:t>Kuvvet ve Hareket · Konu 02 · İki boyutta sabit ivmeli hareket</a:t>
             </a:r>
             <a:endParaRPr lang="en-US" sz="1050" dirty="0"/>
           </a:p>
@@ -18934,7 +18934,7 @@
                 <a:ea typeface="Calibri" pitchFamily="34" charset="-122"/>
                 <a:cs typeface="Calibri" pitchFamily="34" charset="-120"/>
               </a:rPr>
-              <a:t>Kuvvet ve Hareket · Konu 03 · İki boyutta sabit ivmeli hareket</a:t>
+              <a:t>Kuvvet ve Hareket · Konu 02 · İki boyutta sabit ivmeli hareket</a:t>
             </a:r>
             <a:endParaRPr lang="en-US" sz="1050" dirty="0"/>
           </a:p>
@@ -19763,7 +19763,7 @@
                 <a:ea typeface="Calibri" pitchFamily="34" charset="-122"/>
                 <a:cs typeface="Calibri" pitchFamily="34" charset="-120"/>
               </a:rPr>
-              <a:t>Kuvvet ve Hareket · Konu 03 · İki boyutta sabit ivmeli hareket</a:t>
+              <a:t>Kuvvet ve Hareket · Konu 02 · İki boyutta sabit ivmeli hareket</a:t>
             </a:r>
             <a:endParaRPr lang="en-US" sz="1050" dirty="0"/>
           </a:p>
@@ -20247,7 +20247,7 @@
                 <a:ea typeface="Calibri" pitchFamily="34" charset="-122"/>
                 <a:cs typeface="Calibri" pitchFamily="34" charset="-120"/>
               </a:rPr>
-              <a:t>Kuvvet ve Hareket · Konu 03 · İki boyutta sabit ivmeli hareket</a:t>
+              <a:t>Kuvvet ve Hareket · Konu 02 · İki boyutta sabit ivmeli hareket</a:t>
             </a:r>
             <a:endParaRPr lang="en-US" sz="1050" dirty="0"/>
           </a:p>

</xml_diff>